<commit_message>
docs: update platform overview PPTX with WASM mode
- Slide 1: 'One binary, five surfaces' (was four); CLI now lists wasm-bundle/relay
- Slide 2: Added browser-native WASM bullet with wa-sqlite and relay
- Slide 3: 'Three run modes, one runtime'; added wasm to architecture
- Slide 4: Added wasm-bundle and relay commands with descriptions
- Slide 12: Added WASM API section with k.connect_sqlite, k.db_*, IndexedDB, localStorage, fetch, relay, etc.
</commit_message>
<xml_diff>
--- a/docs/kalua-platform-overview.pptx
+++ b/docs/kalua-platform-overview.pptx
@@ -4674,7 +4674,7 @@
                 </a:solidFill>
                 <a:latin typeface="Calibri"/>
               </a:rPr>
-              <a:t>One binary, four surfaces</a:t>
+              <a:t>One binary, five surfaces</a:t>
             </a:r>
           </a:p>
           <a:p>
@@ -11083,6 +11083,50 @@
           <a:p>
             <a:pPr algn="l">
               <a:lnSpc>
+                <a:spcPct val="100000"/>
+              </a:lnSpc>
+              <a:spcBef>
+                <a:spcPts val="0"/>
+              </a:spcBef>
+              <a:spcAft>
+                <a:spcPts val="300"/>
+              </a:spcAft>
+            </a:pPr>
+            <a:r>
+              <a:rPr sz="1000" b="0" i="0">
+                <a:solidFill>
+                  <a:srgbClr val="1F2933"/>
+                </a:solidFill>
+                <a:latin typeface="Calibri"/>
+              </a:rPr>
+              <a:t>WASM (wasm)</a:t>
+            </a:r>
+          </a:p>
+          <a:p>
+            <a:pPr algn="l">
+              <a:lnSpc>
+                <a:spcPct val="100000"/>
+              </a:lnSpc>
+              <a:spcBef>
+                <a:spcPts val="0"/>
+              </a:spcBef>
+              <a:spcAft>
+                <a:spcPts val="300"/>
+              </a:spcAft>
+            </a:pPr>
+            <a:r>
+              <a:rPr sz="1000" b="0" i="0">
+                <a:solidFill>
+                  <a:srgbClr val="1F2933"/>
+                </a:solidFill>
+                <a:latin typeface="Calibri"/>
+              </a:rPr>
+              <a:t>k.connect_sqlite  k.db_*  k.file_* (IndexedDB)  k.param_* (localStorage)  k.http_request (fetch)  k.pick_file  k.relay.*  k.screen_size  k.net_ok  k.ping  k.locale</a:t>
+            </a:r>
+          </a:p>
+          <a:p>
+            <a:pPr algn="l">
+              <a:lnSpc>
                 <a:spcPct val="110000"/>
               </a:lnSpc>
               <a:spcBef>
@@ -20704,7 +20748,7 @@
                 </a:solidFill>
                 <a:latin typeface="Calibri"/>
               </a:rPr>
-              <a:t>Two run modes, one runtime</a:t>
+              <a:t>Three run modes, one runtime</a:t>
             </a:r>
           </a:p>
         </p:txBody>
@@ -24108,7 +24152,51 @@
                           </a:solidFill>
                           <a:latin typeface="Calibri"/>
                         </a:rPr>
-                        <a:t>mcp</a:t>
+                        <a:t>wasm-bundle</a:t>
+                      </a:r>
+                    </a:p>
+                    <a:p>
+                      <a:pPr algn="l">
+                        <a:lnSpc>
+                          <a:spcPct val="100000"/>
+                        </a:lnSpc>
+                        <a:spcBef>
+                          <a:spcPts val="0"/>
+                        </a:spcBef>
+                        <a:spcAft>
+                          <a:spcPts val="300"/>
+                        </a:spcAft>
+                      </a:pPr>
+                      <a:r>
+                        <a:rPr sz="1000" b="0" i="0">
+                          <a:solidFill>
+                            <a:srgbClr val="1F2933"/>
+                          </a:solidFill>
+                          <a:latin typeface="Calibri"/>
+                        </a:rPr>
+                        <a:t>Build WASM bundle for browser (self-contained index.html + KALUA.wasm)</a:t>
+                      </a:r>
+                    </a:p>
+                    <a:p>
+                      <a:pPr algn="l">
+                        <a:lnSpc>
+                          <a:spcPct val="100000"/>
+                        </a:lnSpc>
+                        <a:spcBef>
+                          <a:spcPts val="0"/>
+                        </a:spcBef>
+                        <a:spcAft>
+                          <a:spcPts val="300"/>
+                        </a:spcAft>
+                      </a:pPr>
+                      <a:r>
+                        <a:rPr sz="1000" b="0" i="0">
+                          <a:solidFill>
+                            <a:srgbClr val="1F2933"/>
+                          </a:solidFill>
+                          <a:latin typeface="Calibri"/>
+                        </a:rPr>
+                        <a:t>relay</a:t>
                       </a:r>
                     </a:p>
                   </a:txBody>
@@ -24168,7 +24256,7 @@
                           </a:solidFill>
                           <a:latin typeface="Calibri"/>
                         </a:rPr>
-                        <a:t>Model Context Protocol server over stdio (protocol 2025-06-18) for AI agents</a:t>
+                        <a:t>Run relay server for MySQL/PG/MSSQL/FTP/SMTP/POP3/TCP</a:t>
                       </a:r>
                     </a:p>
                   </a:txBody>

</xml_diff>

<commit_message>
docs: update USER_GUIDE & platform overview with M5 WASM facts
- USER_GUIDE: add WASM as a 3rd run mode (§1.1), brain/hands architecture note
  (§1.2), wasm-bundle/relay CLI (§3.4, §3.6, new §3.8), and full
  chapter 8 (WASM Mode — 100% client-side, brain/hands split, relay,
  in-browser bindings)
- kalua-platform-overview.pptx: slide 0 (add In-browser surface + Browse
  card), slide 2 (Four run modes + WASM block), slide 3 CLI table
  (wasm-bundle/relay refresh), slide 11 (WASM bindings updated to M5
  bindings + relay), slide 14 (three run modes in summary)

go test ./... and wasm build still green.
</commit_message>
<xml_diff>
--- a/docs/kalua-platform-overview.pptx
+++ b/docs/kalua-platform-overview.pptx
@@ -4656,113 +4656,33 @@
           </a:bodyPr>
           <a:lstStyle/>
           <a:p>
-            <a:pPr algn="l">
-              <a:lnSpc>
-                <a:spcPct val="100000"/>
-              </a:lnSpc>
-              <a:spcBef>
-                <a:spcPts val="0"/>
-              </a:spcBef>
-              <a:spcAft>
-                <a:spcPts val="600"/>
-              </a:spcAft>
-            </a:pPr>
-            <a:r>
-              <a:rPr sz="1100" b="1" i="0">
-                <a:solidFill>
-                  <a:srgbClr val="2F5D8C"/>
-                </a:solidFill>
-                <a:latin typeface="Calibri"/>
-              </a:rPr>
-              <a:t>One binary, five surfaces</a:t>
-            </a:r>
-          </a:p>
-          <a:p>
-            <a:pPr algn="l">
-              <a:lnSpc>
-                <a:spcPct val="100000"/>
-              </a:lnSpc>
-              <a:spcBef>
-                <a:spcPts val="0"/>
-              </a:spcBef>
-              <a:spcAft>
-                <a:spcPts val="300"/>
-              </a:spcAft>
-            </a:pPr>
-            <a:r>
-              <a:rPr sz="1000" b="0" i="0">
-                <a:solidFill>
-                  <a:srgbClr val="1F2933"/>
-                </a:solidFill>
-                <a:latin typeface="Calibri"/>
-              </a:rPr>
+            <a:r>
+              <a:t>One binary, every surface</a:t>
+            </a:r>
+          </a:p>
+          <a:p>
+            <a:r>
               <a:t>•  CLI  ·  run / serve / check / builder / ai</a:t>
             </a:r>
           </a:p>
           <a:p>
-            <a:pPr algn="l">
-              <a:lnSpc>
-                <a:spcPct val="100000"/>
-              </a:lnSpc>
-              <a:spcBef>
-                <a:spcPts val="0"/>
-              </a:spcBef>
-              <a:spcAft>
-                <a:spcPts val="300"/>
-              </a:spcAft>
-            </a:pPr>
-            <a:r>
-              <a:rPr sz="1000" b="0" i="0">
-                <a:solidFill>
-                  <a:srgbClr val="1F2933"/>
-                </a:solidFill>
-                <a:latin typeface="Calibri"/>
-              </a:rPr>
+            <a:r>
               <a:t>•  Editor  ·  LSP + VSCode extension</a:t>
             </a:r>
           </a:p>
           <a:p>
-            <a:pPr algn="l">
-              <a:lnSpc>
-                <a:spcPct val="100000"/>
-              </a:lnSpc>
-              <a:spcBef>
-                <a:spcPts val="0"/>
-              </a:spcBef>
-              <a:spcAft>
-                <a:spcPts val="300"/>
-              </a:spcAft>
-            </a:pPr>
-            <a:r>
-              <a:rPr sz="1000" b="0" i="0">
-                <a:solidFill>
-                  <a:srgbClr val="1F2933"/>
-                </a:solidFill>
-                <a:latin typeface="Calibri"/>
-              </a:rPr>
+            <a:r>
               <a:t>•  Browser  ·  pixel-accurate Builder preview</a:t>
             </a:r>
           </a:p>
           <a:p>
-            <a:pPr algn="l">
-              <a:lnSpc>
-                <a:spcPct val="100000"/>
-              </a:lnSpc>
-              <a:spcBef>
-                <a:spcPts val="0"/>
-              </a:spcBef>
-              <a:spcAft>
-                <a:spcPts val="300"/>
-              </a:spcAft>
-            </a:pPr>
-            <a:r>
-              <a:rPr sz="1000" b="0" i="0">
-                <a:solidFill>
-                  <a:srgbClr val="1F2933"/>
-                </a:solidFill>
-                <a:latin typeface="Calibri"/>
-              </a:rPr>
+            <a:r>
               <a:t>•  Agents  ·  MCP server (protocol 2025-06-18)</a:t>
+            </a:r>
+          </a:p>
+          <a:p>
+            <a:r>
+              <a:t>•  In-browser  ·  wasm-bundle → static dist/, no server</a:t>
             </a:r>
           </a:p>
         </p:txBody>
@@ -4808,6 +4728,62 @@
                 <a:latin typeface="Calibri"/>
               </a:rPr>
               <a:t>Source of truth: docs/USER_GUIDE.md   ·   High-level platform walkthrough</a:t>
+            </a:r>
+          </a:p>
+        </p:txBody>
+      </p:sp>
+      <p:sp>
+        <p:nvSpPr>
+          <p:cNvPr id="24" name="TextBox 23"/>
+          <p:cNvSpPr txBox="1"/>
+          <p:nvPr/>
+        </p:nvSpPr>
+        <p:spPr>
+          <a:xfrm>
+            <a:off x="10332720" y="3291840"/>
+            <a:ext cx="1737360" cy="274320"/>
+          </a:xfrm>
+          <a:prstGeom prst="rect">
+            <a:avLst/>
+          </a:prstGeom>
+          <a:noFill/>
+        </p:spPr>
+        <p:txBody>
+          <a:bodyPr wrap="none">
+            <a:spAutoFit/>
+          </a:bodyPr>
+          <a:lstStyle/>
+          <a:p>
+            <a:r>
+              <a:t>Browse</a:t>
+            </a:r>
+          </a:p>
+        </p:txBody>
+      </p:sp>
+      <p:sp>
+        <p:nvSpPr>
+          <p:cNvPr id="25" name="TextBox 24"/>
+          <p:cNvSpPr txBox="1"/>
+          <p:nvPr/>
+        </p:nvSpPr>
+        <p:spPr>
+          <a:xfrm>
+            <a:off x="10332720" y="3566160"/>
+            <a:ext cx="1737360" cy="822960"/>
+          </a:xfrm>
+          <a:prstGeom prst="rect">
+            <a:avLst/>
+          </a:prstGeom>
+          <a:noFill/>
+        </p:spPr>
+        <p:txBody>
+          <a:bodyPr wrap="none">
+            <a:spAutoFit/>
+          </a:bodyPr>
+          <a:lstStyle/>
+          <a:p>
+            <a:r>
+              <a:t>•  wasm-bundle → static page, 100% client-side</a:t>
             </a:r>
           </a:p>
         </p:txBody>
@@ -11059,113 +11035,33 @@
           </a:bodyPr>
           <a:lstStyle/>
           <a:p>
-            <a:pPr algn="l">
-              <a:lnSpc>
-                <a:spcPct val="100000"/>
-              </a:lnSpc>
-              <a:spcBef>
-                <a:spcPts val="0"/>
-              </a:spcBef>
-              <a:spcAft>
-                <a:spcPts val="300"/>
-              </a:spcAft>
-            </a:pPr>
-            <a:r>
-              <a:rPr sz="1100" b="1" i="0">
-                <a:solidFill>
-                  <a:srgbClr val="C62828"/>
-                </a:solidFill>
-                <a:latin typeface="Calibri"/>
-              </a:rPr>
+            <a:r>
               <a:t>Server (serve)</a:t>
             </a:r>
           </a:p>
           <a:p>
-            <a:pPr algn="l">
-              <a:lnSpc>
-                <a:spcPct val="100000"/>
-              </a:lnSpc>
-              <a:spcBef>
-                <a:spcPts val="0"/>
-              </a:spcBef>
-              <a:spcAft>
-                <a:spcPts val="300"/>
-              </a:spcAft>
-            </a:pPr>
-            <a:r>
-              <a:rPr sz="1000" b="0" i="0">
-                <a:solidFill>
-                  <a:srgbClr val="1F2933"/>
-                </a:solidFill>
-                <a:latin typeface="Calibri"/>
-              </a:rPr>
+            <a:r>
+              <a:t>`k.shared.*`  `k.ws.*`  `k.tcp.*`</a:t>
+            </a:r>
+          </a:p>
+          <a:p>
+            <a:r>
+              <a:t>Cross-worker state, WS/TCP push</a:t>
+            </a:r>
+          </a:p>
+          <a:p>
+            <a:r>
               <a:t>WASM (wasm)</a:t>
             </a:r>
           </a:p>
           <a:p>
-            <a:pPr algn="l">
-              <a:lnSpc>
-                <a:spcPct val="100000"/>
-              </a:lnSpc>
-              <a:spcBef>
-                <a:spcPts val="0"/>
-              </a:spcBef>
-              <a:spcAft>
-                <a:spcPts val="300"/>
-              </a:spcAft>
-            </a:pPr>
-            <a:r>
-              <a:rPr sz="1000" b="0" i="0">
-                <a:solidFill>
-                  <a:srgbClr val="1F2933"/>
-                </a:solidFill>
-                <a:latin typeface="Calibri"/>
-              </a:rPr>
-              <a:t>k.connect_sqlite  k.db_*  k.file_* (IndexedDB)  k.param_* (localStorage)  k.http_request (fetch)  k.pick_file  k.relay.*  k.screen_size  k.net_ok  k.ping  k.locale</a:t>
-            </a:r>
-          </a:p>
-          <a:p>
-            <a:pPr algn="l">
-              <a:lnSpc>
-                <a:spcPct val="110000"/>
-              </a:lnSpc>
-              <a:spcBef>
-                <a:spcPts val="0"/>
-              </a:spcBef>
-              <a:spcAft>
-                <a:spcPts val="0"/>
-              </a:spcAft>
-            </a:pPr>
-            <a:r>
-              <a:rPr sz="800" b="0" i="0">
-                <a:solidFill>
-                  <a:srgbClr val="1F2933"/>
-                </a:solidFill>
-                <a:latin typeface="Menlo"/>
-              </a:rPr>
-              <a:t>`k.shared.*`  `k.ws.*`  `k.tcp.*`</a:t>
-            </a:r>
-          </a:p>
-          <a:p>
-            <a:pPr algn="l">
-              <a:lnSpc>
-                <a:spcPct val="108000"/>
-              </a:lnSpc>
-              <a:spcBef>
-                <a:spcPts val="300"/>
-              </a:spcBef>
-              <a:spcAft>
-                <a:spcPts val="0"/>
-              </a:spcAft>
-            </a:pPr>
-            <a:r>
-              <a:rPr sz="850" b="0" i="0">
-                <a:solidFill>
-                  <a:srgbClr val="5A6673"/>
-                </a:solidFill>
-                <a:latin typeface="Calibri"/>
-              </a:rPr>
-              <a:t>Cross-worker state, WS/TCP push</a:t>
+            <a:r>
+              <a:t>browser-only:  k.file_* (IndexedDB)  k.param_* (localStorage)  k.http_request (fetch)  k.screen_size  k.net_ok  k.ping  k.locale</a:t>
+            </a:r>
+          </a:p>
+          <a:p>
+            <a:r>
+              <a:t>SQLite via wa-sqlite (k.connect_sqlite / k.db_*); relay bridges MySQL/PG/MSSQL/FTP/SMTP/POP3/TCP (k.relay.*)</a:t>
             </a:r>
           </a:p>
         </p:txBody>
@@ -17926,123 +17822,18 @@
           </a:bodyPr>
           <a:lstStyle/>
           <a:p>
-            <a:pPr algn="l">
-              <a:lnSpc>
-                <a:spcPct val="105000"/>
-              </a:lnSpc>
-              <a:spcBef>
-                <a:spcPts val="0"/>
-              </a:spcBef>
-              <a:spcAft>
-                <a:spcPts val="500"/>
-              </a:spcAft>
-            </a:pPr>
-            <a:r>
-              <a:rPr sz="1000" b="0" i="0">
-                <a:solidFill>
-                  <a:srgbClr val="1F2933"/>
-                </a:solidFill>
-                <a:latin typeface="Calibri"/>
-              </a:rPr>
-              <a:t>•  </a:t>
-            </a:r>
-            <a:r>
-              <a:rPr sz="1000" b="1" i="0">
-                <a:solidFill>
-                  <a:srgbClr val="1F2933"/>
-                </a:solidFill>
-                <a:latin typeface="Calibri"/>
-              </a:rPr>
-              <a:t>One binary, two run modes.</a:t>
-            </a:r>
-            <a:r>
-              <a:rPr sz="1000" b="0" i="0">
-                <a:solidFill>
-                  <a:srgbClr val="1F2933"/>
-                </a:solidFill>
-                <a:latin typeface="Calibri"/>
-              </a:rPr>
-              <a:t> `run` for browser apps, `serve` for headless APIs — same scripts, same `k.*` API.</a:t>
-            </a:r>
-          </a:p>
-          <a:p>
-            <a:pPr algn="l">
-              <a:lnSpc>
-                <a:spcPct val="105000"/>
-              </a:lnSpc>
-              <a:spcBef>
-                <a:spcPts val="0"/>
-              </a:spcBef>
-              <a:spcAft>
-                <a:spcPts val="500"/>
-              </a:spcAft>
-            </a:pPr>
-            <a:r>
-              <a:rPr sz="1000" b="0" i="0">
-                <a:solidFill>
-                  <a:srgbClr val="1F2933"/>
-                </a:solidFill>
-                <a:latin typeface="Calibri"/>
-              </a:rPr>
-              <a:t>•  </a:t>
-            </a:r>
-            <a:r>
-              <a:rPr sz="1000" b="1" i="0">
-                <a:solidFill>
-                  <a:srgbClr val="1F2933"/>
-                </a:solidFill>
-                <a:latin typeface="Calibri"/>
-              </a:rPr>
-              <a:t>Flags can be persisted.</a:t>
-            </a:r>
-            <a:r>
-              <a:rPr sz="1000" b="0" i="0">
-                <a:solidFill>
-                  <a:srgbClr val="1F2933"/>
-                </a:solidFill>
-                <a:latin typeface="Calibri"/>
-              </a:rPr>
-              <a:t> Drop them in `KALUA.INI`; command-line flags always win.</a:t>
-            </a:r>
-          </a:p>
-          <a:p>
-            <a:pPr algn="l">
-              <a:lnSpc>
-                <a:spcPct val="105000"/>
-              </a:lnSpc>
-              <a:spcBef>
-                <a:spcPts val="0"/>
-              </a:spcBef>
-              <a:spcAft>
-                <a:spcPts val="500"/>
-              </a:spcAft>
-            </a:pPr>
-            <a:r>
-              <a:rPr sz="1000" b="0" i="0">
-                <a:solidFill>
-                  <a:srgbClr val="1F2933"/>
-                </a:solidFill>
-                <a:latin typeface="Calibri"/>
-              </a:rPr>
-              <a:t>•  </a:t>
-            </a:r>
-            <a:r>
-              <a:rPr sz="1000" b="1" i="0">
-                <a:solidFill>
-                  <a:srgbClr val="1F2933"/>
-                </a:solidFill>
-                <a:latin typeface="Calibri"/>
-              </a:rPr>
-              <a:t>Design, generate and verify in one toolchain.</a:t>
-            </a:r>
-            <a:r>
-              <a:rPr sz="1000" b="0" i="0">
-                <a:solidFill>
-                  <a:srgbClr val="1F2933"/>
-                </a:solidFill>
-                <a:latin typeface="Calibri"/>
-              </a:rPr>
-              <a:t> Builder for structure, `ai` for drafts, `check` for correctness, `mcp` for agents.</a:t>
+            <a:r>
+              <a:t>•  One binary, three run modes. `run` for browser apps, `wasm-bundle` for 100% client-side static pages, `serve` for headless APIs — same scripts, same `k.*` API.</a:t>
+            </a:r>
+          </a:p>
+          <a:p>
+            <a:r>
+              <a:t>•  Flags can be persisted. Drop them in `KALUA.INI`; command-line flags always win.</a:t>
+            </a:r>
+          </a:p>
+          <a:p>
+            <a:r>
+              <a:t>•  Design, generate and verify in one toolchain. Builder for structure, `ai` for drafts, `check` for correctness, `mcp` for agents.</a:t>
             </a:r>
           </a:p>
         </p:txBody>
@@ -20730,25 +20521,8 @@
           </a:bodyPr>
           <a:lstStyle/>
           <a:p>
-            <a:pPr algn="l">
-              <a:lnSpc>
-                <a:spcPct val="100000"/>
-              </a:lnSpc>
-              <a:spcBef>
-                <a:spcPts val="0"/>
-              </a:spcBef>
-              <a:spcAft>
-                <a:spcPts val="0"/>
-              </a:spcAft>
-            </a:pPr>
-            <a:r>
-              <a:rPr sz="2500" b="1" i="0">
-                <a:solidFill>
-                  <a:srgbClr val="2F5D8C"/>
-                </a:solidFill>
-                <a:latin typeface="Calibri"/>
-              </a:rPr>
-              <a:t>Three run modes, one runtime</a:t>
+            <a:r>
+              <a:t>Four run modes, one runtime</a:t>
             </a:r>
           </a:p>
         </p:txBody>
@@ -23001,6 +22775,67 @@
                 <a:latin typeface="Calibri"/>
               </a:rPr>
               <a:t>form/control bindings raise a runtime error</a:t>
+            </a:r>
+          </a:p>
+        </p:txBody>
+      </p:sp>
+      <p:sp>
+        <p:nvSpPr>
+          <p:cNvPr id="47" name="TextBox 46"/>
+          <p:cNvSpPr txBox="1"/>
+          <p:nvPr/>
+        </p:nvSpPr>
+        <p:spPr>
+          <a:xfrm>
+            <a:off x="685800" y="5212080"/>
+            <a:ext cx="10881360" cy="274320"/>
+          </a:xfrm>
+          <a:prstGeom prst="rect">
+            <a:avLst/>
+          </a:prstGeom>
+          <a:noFill/>
+        </p:spPr>
+        <p:txBody>
+          <a:bodyPr wrap="none">
+            <a:spAutoFit/>
+          </a:bodyPr>
+          <a:lstStyle/>
+          <a:p>
+            <a:r>
+              <a:t>KALUA wasm — run 100% client-side</a:t>
+            </a:r>
+          </a:p>
+        </p:txBody>
+      </p:sp>
+      <p:sp>
+        <p:nvSpPr>
+          <p:cNvPr id="48" name="TextBox 47"/>
+          <p:cNvSpPr txBox="1"/>
+          <p:nvPr/>
+        </p:nvSpPr>
+        <p:spPr>
+          <a:xfrm>
+            <a:off x="685800" y="5504688"/>
+            <a:ext cx="10881360" cy="640080"/>
+          </a:xfrm>
+          <a:prstGeom prst="rect">
+            <a:avLst/>
+          </a:prstGeom>
+          <a:noFill/>
+        </p:spPr>
+        <p:txBody>
+          <a:bodyPr wrap="none">
+            <a:spAutoFit/>
+          </a:bodyPr>
+          <a:lstStyle/>
+          <a:p>
+            <a:r>
+              <a:t>•  wasm-bundle → static index.html + KALUA.wasm, no server · runs the whole runtime in-page</a:t>
+            </a:r>
+          </a:p>
+          <a:p>
+            <a:r>
+              <a:t>•  Go „brain“ (routing / state / rendering) + app.minimal.js „hands“ · optional relay bridges MySQL/PG/MSSQL/FTP/SMTP/POP3/TCP</a:t>
             </a:r>
           </a:p>
         </p:txBody>
@@ -24137,66 +23972,8 @@
                     <a:bodyPr wrap="square"/>
                     <a:lstStyle/>
                     <a:p>
-                      <a:pPr algn="l">
-                        <a:lnSpc>
-                          <a:spcPct val="95000"/>
-                        </a:lnSpc>
-                        <a:spcAft>
-                          <a:spcPts val="0"/>
-                        </a:spcAft>
-                      </a:pPr>
                       <a:r>
-                        <a:rPr sz="1050" b="1" i="0">
-                          <a:solidFill>
-                            <a:srgbClr val="8A6D1F"/>
-                          </a:solidFill>
-                          <a:latin typeface="Calibri"/>
-                        </a:rPr>
                         <a:t>wasm-bundle</a:t>
-                      </a:r>
-                    </a:p>
-                    <a:p>
-                      <a:pPr algn="l">
-                        <a:lnSpc>
-                          <a:spcPct val="100000"/>
-                        </a:lnSpc>
-                        <a:spcBef>
-                          <a:spcPts val="0"/>
-                        </a:spcBef>
-                        <a:spcAft>
-                          <a:spcPts val="300"/>
-                        </a:spcAft>
-                      </a:pPr>
-                      <a:r>
-                        <a:rPr sz="1000" b="0" i="0">
-                          <a:solidFill>
-                            <a:srgbClr val="1F2933"/>
-                          </a:solidFill>
-                          <a:latin typeface="Calibri"/>
-                        </a:rPr>
-                        <a:t>Build WASM bundle for browser (self-contained index.html + KALUA.wasm)</a:t>
-                      </a:r>
-                    </a:p>
-                    <a:p>
-                      <a:pPr algn="l">
-                        <a:lnSpc>
-                          <a:spcPct val="100000"/>
-                        </a:lnSpc>
-                        <a:spcBef>
-                          <a:spcPts val="0"/>
-                        </a:spcBef>
-                        <a:spcAft>
-                          <a:spcPts val="300"/>
-                        </a:spcAft>
-                      </a:pPr>
-                      <a:r>
-                        <a:rPr sz="1000" b="0" i="0">
-                          <a:solidFill>
-                            <a:srgbClr val="1F2933"/>
-                          </a:solidFill>
-                          <a:latin typeface="Calibri"/>
-                        </a:rPr>
-                        <a:t>relay</a:t>
                       </a:r>
                     </a:p>
                   </a:txBody>
@@ -24211,22 +23988,8 @@
                     <a:bodyPr wrap="square"/>
                     <a:lstStyle/>
                     <a:p>
-                      <a:pPr algn="l">
-                        <a:lnSpc>
-                          <a:spcPct val="95000"/>
-                        </a:lnSpc>
-                        <a:spcAft>
-                          <a:spcPts val="0"/>
-                        </a:spcAft>
-                      </a:pPr>
                       <a:r>
-                        <a:rPr sz="1050" b="0" i="0">
-                          <a:solidFill>
-                            <a:srgbClr val="1F2933"/>
-                          </a:solidFill>
-                          <a:latin typeface="Calibri"/>
-                        </a:rPr>
-                        <a:t>—</a:t>
+                        <a:t>`&lt;app.lua&gt;` [-o dist/] [--relay]   (relay = localhost bridge)</a:t>
                       </a:r>
                     </a:p>
                   </a:txBody>
@@ -24241,22 +24004,8 @@
                     <a:bodyPr wrap="square"/>
                     <a:lstStyle/>
                     <a:p>
-                      <a:pPr algn="l">
-                        <a:lnSpc>
-                          <a:spcPct val="95000"/>
-                        </a:lnSpc>
-                        <a:spcAft>
-                          <a:spcPts val="0"/>
-                        </a:spcAft>
-                      </a:pPr>
                       <a:r>
-                        <a:rPr sz="1050" b="0" i="0">
-                          <a:solidFill>
-                            <a:srgbClr val="1F2933"/>
-                          </a:solidFill>
-                          <a:latin typeface="Calibri"/>
-                        </a:rPr>
-                        <a:t>Run relay server for MySQL/PG/MSSQL/FTP/SMTP/POP3/TCP</a:t>
+                        <a:t>Self-contained static page (index.html + KALUA.wasm) — runs 100% client-side; --relay also ships the localhost DB/comm bridge</a:t>
                       </a:r>
                     </a:p>
                   </a:txBody>

</xml_diff>